<commit_message>
Excel: keep the team's Garamond formatting on new rows, English-only names; contact deck names in English
Co-Authored-By: Claude Fable 5.1 <noreply@anthropic.com>
Claude-Session: https://claude.ai/code/session_01REVwghctKjYh8VQ919ThdA
</commit_message>
<xml_diff>
--- a/policies/Three_countries_to_contact.pptx
+++ b/policies/Three_countries_to_contact.pptx
@@ -3034,7 +3034,7 @@
                 <a:ea typeface="Calibri" pitchFamily="34" charset="-122"/>
                 <a:cs typeface="Calibri" pitchFamily="34" charset="-120"/>
               </a:rPr>
-              <a:t>Ministère de l'Éducation du Québec, human-resources and workforce planning branch for the school network (Direction générale des relations du travail / ressources humaines du réseau).</a:t>
+              <a:t>Quebec Ministry of Education, human-resources and workforce-planning branch for the school network.</a:t>
             </a:r>
             <a:endParaRPr lang="en-US" sz="1250" dirty="0"/>
           </a:p>
@@ -3661,7 +3661,7 @@
                 <a:ea typeface="Calibri" pitchFamily="34" charset="-122"/>
                 <a:cs typeface="Calibri" pitchFamily="34" charset="-120"/>
               </a:rPr>
-              <a:t>Ministry of Education, Culture and Science (OCW), primary education directorate, and DUS-I, the agency that administered the grant.</a:t>
+              <a:t>Dutch Ministry of Education, Culture and Science, primary-education directorate, and the ministry's subsidy agency (DUS-I) that administered the grant.</a:t>
             </a:r>
             <a:endParaRPr lang="en-US" sz="1250" dirty="0"/>
           </a:p>

</xml_diff>